<commit_message>
Update PowerPoint for song #218 in FUBC - Українські
</commit_message>
<xml_diff>
--- a/fubc-ua/218-Який щасливий я (Пісні Спасенних №216).pptx
+++ b/fubc-ua/218-Який щасливий я (Пісні Спасенних №216).pptx
@@ -1607,7 +1607,7 @@
         </p:nvSpPr>
         <p:spPr>
           <a:xfrm>
-            <a:off x="2561946" y="3547872"/>
+            <a:off x="2661006" y="3547872"/>
             <a:ext cx="0" cy="1386840"/>
           </a:xfrm>
           <a:prstGeom prst="line">
@@ -1630,7 +1630,7 @@
         </p:nvSpPr>
         <p:spPr>
           <a:xfrm>
-            <a:off x="9636150" y="3547872"/>
+            <a:off x="9537090" y="3547872"/>
             <a:ext cx="0" cy="1386840"/>
           </a:xfrm>
           <a:prstGeom prst="line">
@@ -1653,8 +1653,8 @@
         </p:nvSpPr>
         <p:spPr>
           <a:xfrm>
-            <a:off x="9768230" y="4010152"/>
-            <a:ext cx="792480" cy="462280"/>
+            <a:off x="9636150" y="3921252"/>
+            <a:ext cx="1097280" cy="640080"/>
           </a:xfrm>
           <a:prstGeom prst="rect">
             <a:avLst/>
@@ -1670,9 +1670,9 @@
               <a:buNone/>
             </a:pPr>
             <a:r>
-              <a:rPr lang="en-US" sz="2600" b="1" dirty="0">
+              <a:rPr lang="en-US" sz="3600" b="1" dirty="0">
                 <a:solidFill>
-                  <a:srgbClr val="8A8A8A"/>
+                  <a:srgbClr val="BBBBBB"/>
                 </a:solidFill>
                 <a:latin typeface="Arial" pitchFamily="34" charset="0"/>
                 <a:ea typeface="Arial" pitchFamily="34" charset="-122"/>
@@ -1680,7 +1680,7 @@
               </a:rPr>
               <a:t>×2</a:t>
             </a:r>
-            <a:endParaRPr lang="en-US" sz="2600" dirty="0"/>
+            <a:endParaRPr lang="en-US" sz="3600" dirty="0"/>
           </a:p>
         </p:txBody>
       </p:sp>
@@ -1826,7 +1826,7 @@
         </p:nvSpPr>
         <p:spPr>
           <a:xfrm>
-            <a:off x="2561946" y="3547872"/>
+            <a:off x="2661006" y="3547872"/>
             <a:ext cx="0" cy="1386840"/>
           </a:xfrm>
           <a:prstGeom prst="line">
@@ -1849,7 +1849,7 @@
         </p:nvSpPr>
         <p:spPr>
           <a:xfrm>
-            <a:off x="9636150" y="3547872"/>
+            <a:off x="9537090" y="3547872"/>
             <a:ext cx="0" cy="1386840"/>
           </a:xfrm>
           <a:prstGeom prst="line">
@@ -1872,8 +1872,8 @@
         </p:nvSpPr>
         <p:spPr>
           <a:xfrm>
-            <a:off x="9768230" y="4010152"/>
-            <a:ext cx="792480" cy="462280"/>
+            <a:off x="9636150" y="3921252"/>
+            <a:ext cx="1097280" cy="640080"/>
           </a:xfrm>
           <a:prstGeom prst="rect">
             <a:avLst/>
@@ -1889,9 +1889,9 @@
               <a:buNone/>
             </a:pPr>
             <a:r>
-              <a:rPr lang="en-US" sz="2600" b="1" dirty="0">
+              <a:rPr lang="en-US" sz="3600" b="1" dirty="0">
                 <a:solidFill>
-                  <a:srgbClr val="8A8A8A"/>
+                  <a:srgbClr val="BBBBBB"/>
                 </a:solidFill>
                 <a:latin typeface="Arial" pitchFamily="34" charset="0"/>
                 <a:ea typeface="Arial" pitchFamily="34" charset="-122"/>
@@ -1899,7 +1899,7 @@
               </a:rPr>
               <a:t>×2</a:t>
             </a:r>
-            <a:endParaRPr lang="en-US" sz="2600" dirty="0"/>
+            <a:endParaRPr lang="en-US" sz="3600" dirty="0"/>
           </a:p>
         </p:txBody>
       </p:sp>
@@ -2045,7 +2045,7 @@
         </p:nvSpPr>
         <p:spPr>
           <a:xfrm>
-            <a:off x="2561946" y="3547872"/>
+            <a:off x="2661006" y="3547872"/>
             <a:ext cx="0" cy="1386840"/>
           </a:xfrm>
           <a:prstGeom prst="line">
@@ -2068,7 +2068,7 @@
         </p:nvSpPr>
         <p:spPr>
           <a:xfrm>
-            <a:off x="9636150" y="3547872"/>
+            <a:off x="9537090" y="3547872"/>
             <a:ext cx="0" cy="1386840"/>
           </a:xfrm>
           <a:prstGeom prst="line">
@@ -2091,8 +2091,8 @@
         </p:nvSpPr>
         <p:spPr>
           <a:xfrm>
-            <a:off x="9768230" y="4010152"/>
-            <a:ext cx="792480" cy="462280"/>
+            <a:off x="9636150" y="3921252"/>
+            <a:ext cx="1097280" cy="640080"/>
           </a:xfrm>
           <a:prstGeom prst="rect">
             <a:avLst/>
@@ -2108,9 +2108,9 @@
               <a:buNone/>
             </a:pPr>
             <a:r>
-              <a:rPr lang="en-US" sz="2600" b="1" dirty="0">
+              <a:rPr lang="en-US" sz="3600" b="1" dirty="0">
                 <a:solidFill>
-                  <a:srgbClr val="8A8A8A"/>
+                  <a:srgbClr val="BBBBBB"/>
                 </a:solidFill>
                 <a:latin typeface="Arial" pitchFamily="34" charset="0"/>
                 <a:ea typeface="Arial" pitchFamily="34" charset="-122"/>
@@ -2118,7 +2118,7 @@
               </a:rPr>
               <a:t>×2</a:t>
             </a:r>
-            <a:endParaRPr lang="en-US" sz="2600" dirty="0"/>
+            <a:endParaRPr lang="en-US" sz="3600" dirty="0"/>
           </a:p>
         </p:txBody>
       </p:sp>
@@ -2264,7 +2264,7 @@
         </p:nvSpPr>
         <p:spPr>
           <a:xfrm>
-            <a:off x="3102483" y="3547872"/>
+            <a:off x="3201543" y="3547872"/>
             <a:ext cx="0" cy="1386840"/>
           </a:xfrm>
           <a:prstGeom prst="line">
@@ -2287,7 +2287,7 @@
         </p:nvSpPr>
         <p:spPr>
           <a:xfrm>
-            <a:off x="9095613" y="3547872"/>
+            <a:off x="8996553" y="3547872"/>
             <a:ext cx="0" cy="1386840"/>
           </a:xfrm>
           <a:prstGeom prst="line">
@@ -2310,8 +2310,8 @@
         </p:nvSpPr>
         <p:spPr>
           <a:xfrm>
-            <a:off x="9227693" y="4010152"/>
-            <a:ext cx="792480" cy="462280"/>
+            <a:off x="9095613" y="3921252"/>
+            <a:ext cx="1097280" cy="640080"/>
           </a:xfrm>
           <a:prstGeom prst="rect">
             <a:avLst/>
@@ -2327,9 +2327,9 @@
               <a:buNone/>
             </a:pPr>
             <a:r>
-              <a:rPr lang="en-US" sz="2600" b="1" dirty="0">
+              <a:rPr lang="en-US" sz="3600" b="1" dirty="0">
                 <a:solidFill>
-                  <a:srgbClr val="8A8A8A"/>
+                  <a:srgbClr val="BBBBBB"/>
                 </a:solidFill>
                 <a:latin typeface="Arial" pitchFamily="34" charset="0"/>
                 <a:ea typeface="Arial" pitchFamily="34" charset="-122"/>
@@ -2337,7 +2337,7 @@
               </a:rPr>
               <a:t>×2</a:t>
             </a:r>
-            <a:endParaRPr lang="en-US" sz="2600" dirty="0"/>
+            <a:endParaRPr lang="en-US" sz="3600" dirty="0"/>
           </a:p>
         </p:txBody>
       </p:sp>
@@ -2483,7 +2483,7 @@
         </p:nvSpPr>
         <p:spPr>
           <a:xfrm>
-            <a:off x="2773604" y="3547872"/>
+            <a:off x="2872664" y="3547872"/>
             <a:ext cx="0" cy="1386840"/>
           </a:xfrm>
           <a:prstGeom prst="line">
@@ -2506,7 +2506,7 @@
         </p:nvSpPr>
         <p:spPr>
           <a:xfrm>
-            <a:off x="9424492" y="3547872"/>
+            <a:off x="9325432" y="3547872"/>
             <a:ext cx="0" cy="1386840"/>
           </a:xfrm>
           <a:prstGeom prst="line">
@@ -2529,8 +2529,8 @@
         </p:nvSpPr>
         <p:spPr>
           <a:xfrm>
-            <a:off x="9556572" y="4010152"/>
-            <a:ext cx="792480" cy="462280"/>
+            <a:off x="9424492" y="3921252"/>
+            <a:ext cx="1097280" cy="640080"/>
           </a:xfrm>
           <a:prstGeom prst="rect">
             <a:avLst/>
@@ -2546,9 +2546,9 @@
               <a:buNone/>
             </a:pPr>
             <a:r>
-              <a:rPr lang="en-US" sz="2600" b="1" dirty="0">
+              <a:rPr lang="en-US" sz="3600" b="1" dirty="0">
                 <a:solidFill>
-                  <a:srgbClr val="8A8A8A"/>
+                  <a:srgbClr val="BBBBBB"/>
                 </a:solidFill>
                 <a:latin typeface="Arial" pitchFamily="34" charset="0"/>
                 <a:ea typeface="Arial" pitchFamily="34" charset="-122"/>
@@ -2556,7 +2556,7 @@
               </a:rPr>
               <a:t>×2</a:t>
             </a:r>
-            <a:endParaRPr lang="en-US" sz="2600" dirty="0"/>
+            <a:endParaRPr lang="en-US" sz="3600" dirty="0"/>
           </a:p>
         </p:txBody>
       </p:sp>

</xml_diff>